<commit_message>
ranking on 5 hospitals
rnd exp(10 * opinion) + exp(10 * (1-distance))
</commit_message>
<xml_diff>
--- a/extra/Presentation1.pptx
+++ b/extra/Presentation1.pptx
@@ -6,6 +6,7 @@
   </p:sldMasterIdLst>
   <p:sldIdLst>
     <p:sldId id="256" r:id="rId2"/>
+    <p:sldId id="257" r:id="rId3"/>
   </p:sldIdLst>
   <p:sldSz cx="6858000" cy="12192000"/>
   <p:notesSz cx="6858000" cy="9144000"/>
@@ -254,7 +255,7 @@
           <a:p>
             <a:fld id="{E3E30022-66EA-4158-A03A-BF3EA10B51B9}" type="datetimeFigureOut">
               <a:rPr lang="it-IT" smtClean="0"/>
-              <a:t>15/10/2025</a:t>
+              <a:t>16/10/2025</a:t>
             </a:fld>
             <a:endParaRPr lang="it-IT"/>
           </a:p>
@@ -424,7 +425,7 @@
           <a:p>
             <a:fld id="{E3E30022-66EA-4158-A03A-BF3EA10B51B9}" type="datetimeFigureOut">
               <a:rPr lang="it-IT" smtClean="0"/>
-              <a:t>15/10/2025</a:t>
+              <a:t>16/10/2025</a:t>
             </a:fld>
             <a:endParaRPr lang="it-IT"/>
           </a:p>
@@ -604,7 +605,7 @@
           <a:p>
             <a:fld id="{E3E30022-66EA-4158-A03A-BF3EA10B51B9}" type="datetimeFigureOut">
               <a:rPr lang="it-IT" smtClean="0"/>
-              <a:t>15/10/2025</a:t>
+              <a:t>16/10/2025</a:t>
             </a:fld>
             <a:endParaRPr lang="it-IT"/>
           </a:p>
@@ -774,7 +775,7 @@
           <a:p>
             <a:fld id="{E3E30022-66EA-4158-A03A-BF3EA10B51B9}" type="datetimeFigureOut">
               <a:rPr lang="it-IT" smtClean="0"/>
-              <a:t>15/10/2025</a:t>
+              <a:t>16/10/2025</a:t>
             </a:fld>
             <a:endParaRPr lang="it-IT"/>
           </a:p>
@@ -1020,7 +1021,7 @@
           <a:p>
             <a:fld id="{E3E30022-66EA-4158-A03A-BF3EA10B51B9}" type="datetimeFigureOut">
               <a:rPr lang="it-IT" smtClean="0"/>
-              <a:t>15/10/2025</a:t>
+              <a:t>16/10/2025</a:t>
             </a:fld>
             <a:endParaRPr lang="it-IT"/>
           </a:p>
@@ -1252,7 +1253,7 @@
           <a:p>
             <a:fld id="{E3E30022-66EA-4158-A03A-BF3EA10B51B9}" type="datetimeFigureOut">
               <a:rPr lang="it-IT" smtClean="0"/>
-              <a:t>15/10/2025</a:t>
+              <a:t>16/10/2025</a:t>
             </a:fld>
             <a:endParaRPr lang="it-IT"/>
           </a:p>
@@ -1619,7 +1620,7 @@
           <a:p>
             <a:fld id="{E3E30022-66EA-4158-A03A-BF3EA10B51B9}" type="datetimeFigureOut">
               <a:rPr lang="it-IT" smtClean="0"/>
-              <a:t>15/10/2025</a:t>
+              <a:t>16/10/2025</a:t>
             </a:fld>
             <a:endParaRPr lang="it-IT"/>
           </a:p>
@@ -1737,7 +1738,7 @@
           <a:p>
             <a:fld id="{E3E30022-66EA-4158-A03A-BF3EA10B51B9}" type="datetimeFigureOut">
               <a:rPr lang="it-IT" smtClean="0"/>
-              <a:t>15/10/2025</a:t>
+              <a:t>16/10/2025</a:t>
             </a:fld>
             <a:endParaRPr lang="it-IT"/>
           </a:p>
@@ -1832,7 +1833,7 @@
           <a:p>
             <a:fld id="{E3E30022-66EA-4158-A03A-BF3EA10B51B9}" type="datetimeFigureOut">
               <a:rPr lang="it-IT" smtClean="0"/>
-              <a:t>15/10/2025</a:t>
+              <a:t>16/10/2025</a:t>
             </a:fld>
             <a:endParaRPr lang="it-IT"/>
           </a:p>
@@ -2109,7 +2110,7 @@
           <a:p>
             <a:fld id="{E3E30022-66EA-4158-A03A-BF3EA10B51B9}" type="datetimeFigureOut">
               <a:rPr lang="it-IT" smtClean="0"/>
-              <a:t>15/10/2025</a:t>
+              <a:t>16/10/2025</a:t>
             </a:fld>
             <a:endParaRPr lang="it-IT"/>
           </a:p>
@@ -2366,7 +2367,7 @@
           <a:p>
             <a:fld id="{E3E30022-66EA-4158-A03A-BF3EA10B51B9}" type="datetimeFigureOut">
               <a:rPr lang="it-IT" smtClean="0"/>
-              <a:t>15/10/2025</a:t>
+              <a:t>16/10/2025</a:t>
             </a:fld>
             <a:endParaRPr lang="it-IT"/>
           </a:p>
@@ -2579,7 +2580,7 @@
           <a:p>
             <a:fld id="{E3E30022-66EA-4158-A03A-BF3EA10B51B9}" type="datetimeFigureOut">
               <a:rPr lang="it-IT" smtClean="0"/>
-              <a:t>15/10/2025</a:t>
+              <a:t>16/10/2025</a:t>
             </a:fld>
             <a:endParaRPr lang="it-IT"/>
           </a:p>
@@ -3374,6 +3375,385 @@
 </p:sld>
 </file>
 
+<file path=ppt/slides/slide2.xml><?xml version="1.0" encoding="utf-8"?>
+<p:sld xmlns:a="http://schemas.openxmlformats.org/drawingml/2006/main" xmlns:r="http://schemas.openxmlformats.org/officeDocument/2006/relationships" xmlns:p="http://schemas.openxmlformats.org/presentationml/2006/main">
+  <p:cSld>
+    <p:spTree>
+      <p:nvGrpSpPr>
+        <p:cNvPr id="1" name=""/>
+        <p:cNvGrpSpPr/>
+        <p:nvPr/>
+      </p:nvGrpSpPr>
+      <p:grpSpPr>
+        <a:xfrm>
+          <a:off x="0" y="0"/>
+          <a:ext cx="0" cy="0"/>
+          <a:chOff x="0" y="0"/>
+          <a:chExt cx="0" cy="0"/>
+        </a:xfrm>
+      </p:grpSpPr>
+      <p:pic>
+        <p:nvPicPr>
+          <p:cNvPr id="5" name="Picture 4">
+            <a:extLst>
+              <a:ext uri="{FF2B5EF4-FFF2-40B4-BE49-F238E27FC236}">
+                <a16:creationId xmlns:a16="http://schemas.microsoft.com/office/drawing/2014/main" id="{1C178880-6101-7BEE-1210-8E48DACBAFDC}"/>
+              </a:ext>
+            </a:extLst>
+          </p:cNvPr>
+          <p:cNvPicPr>
+            <a:picLocks noChangeAspect="1"/>
+          </p:cNvPicPr>
+          <p:nvPr/>
+        </p:nvPicPr>
+        <p:blipFill>
+          <a:blip r:embed="rId2"/>
+          <a:stretch>
+            <a:fillRect/>
+          </a:stretch>
+        </p:blipFill>
+        <p:spPr>
+          <a:xfrm>
+            <a:off x="118533" y="625962"/>
+            <a:ext cx="2744257" cy="2761463"/>
+          </a:xfrm>
+          <a:prstGeom prst="rect">
+            <a:avLst/>
+          </a:prstGeom>
+        </p:spPr>
+      </p:pic>
+      <p:sp>
+        <p:nvSpPr>
+          <p:cNvPr id="7" name="TextBox 6">
+            <a:extLst>
+              <a:ext uri="{FF2B5EF4-FFF2-40B4-BE49-F238E27FC236}">
+                <a16:creationId xmlns:a16="http://schemas.microsoft.com/office/drawing/2014/main" id="{9EBCED48-DE74-A682-0B86-32169FB52F1C}"/>
+              </a:ext>
+            </a:extLst>
+          </p:cNvPr>
+          <p:cNvSpPr txBox="1"/>
+          <p:nvPr/>
+        </p:nvSpPr>
+        <p:spPr>
+          <a:xfrm>
+            <a:off x="2862790" y="1791531"/>
+            <a:ext cx="3656543" cy="1477328"/>
+          </a:xfrm>
+          <a:prstGeom prst="rect">
+            <a:avLst/>
+          </a:prstGeom>
+          <a:noFill/>
+        </p:spPr>
+        <p:txBody>
+          <a:bodyPr wrap="square">
+            <a:spAutoFit/>
+          </a:bodyPr>
+          <a:lstStyle/>
+          <a:p>
+            <a:r>
+              <a:rPr lang="it-IT" sz="900" dirty="0"/>
+              <a:t>1407 [COMPLESSO OSPEDALIERO CAREGGI - CTO (FI) MISERICORDIA GROSSETO NUOVO OSPEDALE BORGO S.LORENZO (FI) RIUNITI LIVORNO S.GIOVANNI DI DIO-TORREGALLI (FI)]</a:t>
+            </a:r>
+          </a:p>
+          <a:p>
+            <a:r>
+              <a:rPr lang="it-IT" sz="900" dirty="0"/>
+              <a:t>743 [RIUNITI LIVORNO NUOVO OSPEDALE DI PRATO S.STEFANO OSPEDALE SAN JACOPO OSPEDALE S. GIUSEPPE SERRISTORI FIGLINE V.A. (FI)]</a:t>
+            </a:r>
+          </a:p>
+          <a:p>
+            <a:r>
+              <a:rPr lang="it-IT" sz="900" dirty="0"/>
+              <a:t>1166 [OSPEDALE DEL VALDARNO - "S.MARIA DELLA GRUCCIA" COMPLESSO OSPEDALIERO CAREGGI - CTO (FI) OSP. RIUNITI DELLA VAL DI CHIANA MISERICORDIA GROSSETO CIVILE ELBANO PORTOFERRAIO (LI)]</a:t>
+            </a:r>
+          </a:p>
+        </p:txBody>
+      </p:sp>
+      <p:sp>
+        <p:nvSpPr>
+          <p:cNvPr id="8" name="TextBox 7">
+            <a:extLst>
+              <a:ext uri="{FF2B5EF4-FFF2-40B4-BE49-F238E27FC236}">
+                <a16:creationId xmlns:a16="http://schemas.microsoft.com/office/drawing/2014/main" id="{6A5D4F68-92A0-E16D-38A8-AD7BCC7812D3}"/>
+              </a:ext>
+            </a:extLst>
+          </p:cNvPr>
+          <p:cNvSpPr txBox="1"/>
+          <p:nvPr/>
+        </p:nvSpPr>
+        <p:spPr>
+          <a:xfrm>
+            <a:off x="1490661" y="138064"/>
+            <a:ext cx="4325864" cy="369332"/>
+          </a:xfrm>
+          <a:prstGeom prst="rect">
+            <a:avLst/>
+          </a:prstGeom>
+          <a:noFill/>
+        </p:spPr>
+        <p:txBody>
+          <a:bodyPr wrap="none" rtlCol="0">
+            <a:spAutoFit/>
+          </a:bodyPr>
+          <a:lstStyle/>
+          <a:p>
+            <a:r>
+              <a:rPr lang="it-IT" dirty="0"/>
+              <a:t>Test ranking of hospital based on distance</a:t>
+            </a:r>
+          </a:p>
+        </p:txBody>
+      </p:sp>
+      <p:sp>
+        <p:nvSpPr>
+          <p:cNvPr id="9" name="TextBox 8">
+            <a:extLst>
+              <a:ext uri="{FF2B5EF4-FFF2-40B4-BE49-F238E27FC236}">
+                <a16:creationId xmlns:a16="http://schemas.microsoft.com/office/drawing/2014/main" id="{D5F660DB-0F96-9B01-D423-890B411883FD}"/>
+              </a:ext>
+            </a:extLst>
+          </p:cNvPr>
+          <p:cNvSpPr txBox="1"/>
+          <p:nvPr/>
+        </p:nvSpPr>
+        <p:spPr>
+          <a:xfrm>
+            <a:off x="2862790" y="885581"/>
+            <a:ext cx="3487739" cy="646331"/>
+          </a:xfrm>
+          <a:prstGeom prst="rect">
+            <a:avLst/>
+          </a:prstGeom>
+          <a:noFill/>
+        </p:spPr>
+        <p:txBody>
+          <a:bodyPr wrap="square" rtlCol="0">
+            <a:spAutoFit/>
+          </a:bodyPr>
+          <a:lstStyle/>
+          <a:p>
+            <a:r>
+              <a:rPr lang="en-US" sz="1200" dirty="0"/>
+              <a:t>let </a:t>
+            </a:r>
+            <a:r>
+              <a:rPr lang="en-US" sz="1200" dirty="0" err="1"/>
+              <a:t>knownhosp</a:t>
+            </a:r>
+            <a:r>
+              <a:rPr lang="en-US" sz="1200" dirty="0"/>
+              <a:t> </a:t>
+            </a:r>
+            <a:r>
+              <a:rPr lang="en-US" sz="1200" dirty="0" err="1"/>
+              <a:t>rnd:weighted-n-of-list</a:t>
+            </a:r>
+            <a:r>
+              <a:rPr lang="en-US" sz="1200" dirty="0"/>
+              <a:t> 5 </a:t>
+            </a:r>
+            <a:r>
+              <a:rPr lang="en-US" sz="1200" dirty="0" err="1"/>
+              <a:t>listhospitals</a:t>
+            </a:r>
+            <a:r>
+              <a:rPr lang="en-US" sz="1200" dirty="0"/>
+              <a:t>  [h -&gt; (exp(10 * (1 - </a:t>
+            </a:r>
+            <a:r>
+              <a:rPr lang="en-US" sz="1200" dirty="0" err="1"/>
+              <a:t>dist</a:t>
+            </a:r>
+            <a:r>
+              <a:rPr lang="en-US" sz="1200" dirty="0"/>
+              <a:t> self one-of hospital with [id = h] </a:t>
+            </a:r>
+            <a:r>
+              <a:rPr lang="en-US" sz="1200" dirty="0" err="1"/>
+              <a:t>distservicesnorm</a:t>
+            </a:r>
+            <a:r>
+              <a:rPr lang="en-US" sz="1200" dirty="0"/>
+              <a:t>)))]</a:t>
+            </a:r>
+            <a:endParaRPr lang="it-IT" sz="1200" dirty="0"/>
+          </a:p>
+        </p:txBody>
+      </p:sp>
+      <p:sp>
+        <p:nvSpPr>
+          <p:cNvPr id="11" name="TextBox 10">
+            <a:extLst>
+              <a:ext uri="{FF2B5EF4-FFF2-40B4-BE49-F238E27FC236}">
+                <a16:creationId xmlns:a16="http://schemas.microsoft.com/office/drawing/2014/main" id="{C5A23DC1-2F73-01EC-EFCC-44A2B1816D81}"/>
+              </a:ext>
+            </a:extLst>
+          </p:cNvPr>
+          <p:cNvSpPr txBox="1"/>
+          <p:nvPr/>
+        </p:nvSpPr>
+        <p:spPr>
+          <a:xfrm>
+            <a:off x="2737377" y="4285994"/>
+            <a:ext cx="3979150" cy="830997"/>
+          </a:xfrm>
+          <a:prstGeom prst="rect">
+            <a:avLst/>
+          </a:prstGeom>
+          <a:noFill/>
+        </p:spPr>
+        <p:txBody>
+          <a:bodyPr wrap="square">
+            <a:spAutoFit/>
+          </a:bodyPr>
+          <a:lstStyle/>
+          <a:p>
+            <a:r>
+              <a:rPr lang="en-US" sz="1200" dirty="0"/>
+              <a:t>let </a:t>
+            </a:r>
+            <a:r>
+              <a:rPr lang="en-US" sz="1200" dirty="0" err="1"/>
+              <a:t>knownhosp</a:t>
+            </a:r>
+            <a:r>
+              <a:rPr lang="en-US" sz="1200" dirty="0"/>
+              <a:t> </a:t>
+            </a:r>
+            <a:r>
+              <a:rPr lang="en-US" sz="1200" dirty="0" err="1"/>
+              <a:t>rnd:weighted-n-of-list</a:t>
+            </a:r>
+            <a:r>
+              <a:rPr lang="en-US" sz="1200" dirty="0"/>
+              <a:t> 5 </a:t>
+            </a:r>
+            <a:r>
+              <a:rPr lang="en-US" sz="1200" dirty="0" err="1"/>
+              <a:t>listhospitals</a:t>
+            </a:r>
+            <a:r>
+              <a:rPr lang="en-US" sz="1200" dirty="0"/>
+              <a:t>  [h -&gt; ( exp(10 * ([</a:t>
+            </a:r>
+            <a:r>
+              <a:rPr lang="en-US" sz="1200" dirty="0" err="1"/>
+              <a:t>ownranking</a:t>
+            </a:r>
+            <a:r>
+              <a:rPr lang="en-US" sz="1200" dirty="0"/>
+              <a:t>] of one-of hospital with [id = h])) +  exp(10 * (1 - </a:t>
+            </a:r>
+            <a:r>
+              <a:rPr lang="en-US" sz="1200" dirty="0" err="1"/>
+              <a:t>dist</a:t>
+            </a:r>
+            <a:r>
+              <a:rPr lang="en-US" sz="1200" dirty="0"/>
+              <a:t> self one-of hospital with [id = h] </a:t>
+            </a:r>
+            <a:r>
+              <a:rPr lang="en-US" sz="1200" dirty="0" err="1"/>
+              <a:t>distservicesnorm</a:t>
+            </a:r>
+            <a:r>
+              <a:rPr lang="en-US" sz="1200" dirty="0"/>
+              <a:t>)))]</a:t>
+            </a:r>
+            <a:endParaRPr lang="it-IT" sz="1200" dirty="0"/>
+          </a:p>
+        </p:txBody>
+      </p:sp>
+      <p:pic>
+        <p:nvPicPr>
+          <p:cNvPr id="13" name="Picture 12">
+            <a:extLst>
+              <a:ext uri="{FF2B5EF4-FFF2-40B4-BE49-F238E27FC236}">
+                <a16:creationId xmlns:a16="http://schemas.microsoft.com/office/drawing/2014/main" id="{7DB75656-BAB7-DFA2-9EAC-6410C4ED0719}"/>
+              </a:ext>
+            </a:extLst>
+          </p:cNvPr>
+          <p:cNvPicPr>
+            <a:picLocks noChangeAspect="1"/>
+          </p:cNvPicPr>
+          <p:nvPr/>
+        </p:nvPicPr>
+        <p:blipFill>
+          <a:blip r:embed="rId3"/>
+          <a:stretch>
+            <a:fillRect/>
+          </a:stretch>
+        </p:blipFill>
+        <p:spPr>
+          <a:xfrm>
+            <a:off x="95591" y="3706910"/>
+            <a:ext cx="2698375" cy="2702763"/>
+          </a:xfrm>
+          <a:prstGeom prst="rect">
+            <a:avLst/>
+          </a:prstGeom>
+        </p:spPr>
+      </p:pic>
+      <p:sp>
+        <p:nvSpPr>
+          <p:cNvPr id="15" name="TextBox 14">
+            <a:extLst>
+              <a:ext uri="{FF2B5EF4-FFF2-40B4-BE49-F238E27FC236}">
+                <a16:creationId xmlns:a16="http://schemas.microsoft.com/office/drawing/2014/main" id="{FFA0B82E-DDA9-E096-4FDB-0233AAFCD489}"/>
+              </a:ext>
+            </a:extLst>
+          </p:cNvPr>
+          <p:cNvSpPr txBox="1"/>
+          <p:nvPr/>
+        </p:nvSpPr>
+        <p:spPr>
+          <a:xfrm>
+            <a:off x="2862790" y="5481178"/>
+            <a:ext cx="3429000" cy="2292935"/>
+          </a:xfrm>
+          <a:prstGeom prst="rect">
+            <a:avLst/>
+          </a:prstGeom>
+          <a:noFill/>
+        </p:spPr>
+        <p:txBody>
+          <a:bodyPr wrap="square">
+            <a:spAutoFit/>
+          </a:bodyPr>
+          <a:lstStyle/>
+          <a:p>
+            <a:r>
+              <a:rPr lang="it-IT" sz="1100" dirty="0"/>
+              <a:t>959 [COMPLESSO OSPEDALIERO CAREGGI - CTO (FI) OSP. RIUNITI DELLA VAL DI CHIANA OSPEDALI PISANI (PI) S.GIOVANNI DI DIO-TORREGALLI (FI) CIVILE CECINA (LI)]</a:t>
+            </a:r>
+          </a:p>
+          <a:p>
+            <a:r>
+              <a:rPr lang="it-IT" sz="1100" dirty="0"/>
+              <a:t>186 [AREA ARETINA NORD AREZZO COMPLESSO OSPEDALIERO CAREGGI - CTO (FI) OSPEDALI PISANI (PI) NUOVO OSPEDALE DI PRATO S.STEFANO OSPEDALE SAN JACOPO]</a:t>
+            </a:r>
+          </a:p>
+          <a:p>
+            <a:r>
+              <a:rPr lang="it-IT" sz="1100" dirty="0"/>
+              <a:t>502 [COMPLESSO OSPEDALIERO CAREGGI - CTO (FI) NUOVO OSPEDALE BORGO S.LORENZO (FI) S.GIOVANNI DI DIO-TORREGALLI (FI) NUOVO OSPEDALE DI PRATO S.STEFANO OSPEDALE SAN LUCA]</a:t>
+            </a:r>
+          </a:p>
+        </p:txBody>
+      </p:sp>
+    </p:spTree>
+    <p:extLst>
+      <p:ext uri="{BB962C8B-B14F-4D97-AF65-F5344CB8AC3E}">
+        <p14:creationId xmlns:p14="http://schemas.microsoft.com/office/powerpoint/2010/main" val="1668580014"/>
+      </p:ext>
+    </p:extLst>
+  </p:cSld>
+  <p:clrMapOvr>
+    <a:masterClrMapping/>
+  </p:clrMapOvr>
+</p:sld>
+</file>
+
 <file path=ppt/theme/theme1.xml><?xml version="1.0" encoding="utf-8"?>
 <a:theme xmlns:a="http://schemas.openxmlformats.org/drawingml/2006/main" name="Office Theme">
   <a:themeElements>

</xml_diff>